<commit_message>
Paquets Debian (auxitext, auxioffice, auxinux-office de transition) ; installation Windows 11 et AuxiText dans install-apps.sh ; présentation vierge 16:9 centrée
- scripts/build-deb.sh : auxioffice embarque son moteur LibreOffice et
  dépend d'auxitext (installable seul) ; auxinux-office (ancien nom)
  installe auxioffice. Versions 0.2.0~beta.1 (une bêta précède la finale).
- install-apps.sh : Windows 11 sous Git Bash (%LOCALAPPDATA%\\Programs, menu
  Démarrer, « Ouvrir avec ») ; AuxiText installé partout ; moteur préparé
  s'il manque.
- vierge.pptx : zones des masques et dispositions à l'échelle du 16:9
  (elles restaient calées sur le 4:3).

Co-Authored-By: Claude Opus 5.5 <noreply@anthropic.com>
</commit_message>
<xml_diff>
--- a/app/src-tauri/templates/vierge.pptx
+++ b/app/src-tauri/templates/vierge.pptx
@@ -136,8 +136,8 @@
         </p:nvSpPr>
         <p:spPr>
           <a:xfrm>
-            <a:off x="685800" y="2130425"/>
-            <a:ext cx="7772400" cy="1470025"/>
+            <a:off x="914377" y="2130425"/>
+            <a:ext cx="10362941" cy="1470025"/>
           </a:xfrm>
         </p:spPr>
         <p:txBody>
@@ -164,8 +164,8 @@
         </p:nvSpPr>
         <p:spPr>
           <a:xfrm>
-            <a:off x="1371600" y="3886200"/>
-            <a:ext cx="6400800" cy="1752600"/>
+            <a:off x="1828754" y="3886200"/>
+            <a:ext cx="8534187" cy="1752600"/>
           </a:xfrm>
         </p:spPr>
         <p:txBody>
@@ -548,8 +548,8 @@
         </p:nvSpPr>
         <p:spPr>
           <a:xfrm>
-            <a:off x="6629400" y="274638"/>
-            <a:ext cx="2057400" cy="5851525"/>
+            <a:off x="8838979" y="274638"/>
+            <a:ext cx="2743131" cy="5851525"/>
           </a:xfrm>
         </p:spPr>
         <p:txBody>
@@ -576,8 +576,8 @@
         </p:nvSpPr>
         <p:spPr>
           <a:xfrm>
-            <a:off x="457200" y="274638"/>
-            <a:ext cx="6019800" cy="5851525"/>
+            <a:off x="609585" y="274638"/>
+            <a:ext cx="8026199" cy="5851525"/>
           </a:xfrm>
         </p:spPr>
         <p:txBody>
@@ -898,8 +898,8 @@
         </p:nvSpPr>
         <p:spPr>
           <a:xfrm>
-            <a:off x="722313" y="4406900"/>
-            <a:ext cx="7772400" cy="1362075"/>
+            <a:off x="963060" y="4406900"/>
+            <a:ext cx="10362941" cy="1362075"/>
           </a:xfrm>
         </p:spPr>
         <p:txBody>
@@ -930,8 +930,8 @@
         </p:nvSpPr>
         <p:spPr>
           <a:xfrm>
-            <a:off x="722313" y="2906713"/>
-            <a:ext cx="7772400" cy="1500187"/>
+            <a:off x="963060" y="2906713"/>
+            <a:ext cx="10362941" cy="1500187"/>
           </a:xfrm>
         </p:spPr>
         <p:txBody>
@@ -1167,8 +1167,8 @@
         </p:nvSpPr>
         <p:spPr>
           <a:xfrm>
-            <a:off x="457200" y="1600200"/>
-            <a:ext cx="4038600" cy="4525963"/>
+            <a:off x="609585" y="1600200"/>
+            <a:ext cx="5384665" cy="4525963"/>
           </a:xfrm>
         </p:spPr>
         <p:txBody>
@@ -1252,8 +1252,8 @@
         </p:nvSpPr>
         <p:spPr>
           <a:xfrm>
-            <a:off x="4648200" y="1600200"/>
-            <a:ext cx="4038600" cy="4525963"/>
+            <a:off x="6197445" y="1600200"/>
+            <a:ext cx="5384665" cy="4525963"/>
           </a:xfrm>
         </p:spPr>
         <p:txBody>
@@ -1459,8 +1459,8 @@
         </p:nvSpPr>
         <p:spPr>
           <a:xfrm>
-            <a:off x="457200" y="1535113"/>
-            <a:ext cx="4040188" cy="639762"/>
+            <a:off x="609585" y="1535113"/>
+            <a:ext cx="5386783" cy="639762"/>
           </a:xfrm>
         </p:spPr>
         <p:txBody>
@@ -1524,8 +1524,8 @@
         </p:nvSpPr>
         <p:spPr>
           <a:xfrm>
-            <a:off x="457200" y="2174875"/>
-            <a:ext cx="4040188" cy="3951288"/>
+            <a:off x="609585" y="2174875"/>
+            <a:ext cx="5386783" cy="3951288"/>
           </a:xfrm>
         </p:spPr>
         <p:txBody>
@@ -1609,8 +1609,8 @@
         </p:nvSpPr>
         <p:spPr>
           <a:xfrm>
-            <a:off x="4645025" y="1535113"/>
-            <a:ext cx="4041775" cy="639762"/>
+            <a:off x="6193212" y="1535113"/>
+            <a:ext cx="5388899" cy="639762"/>
           </a:xfrm>
         </p:spPr>
         <p:txBody>
@@ -1674,8 +1674,8 @@
         </p:nvSpPr>
         <p:spPr>
           <a:xfrm>
-            <a:off x="4645025" y="2174875"/>
-            <a:ext cx="4041775" cy="3951288"/>
+            <a:off x="6193212" y="2174875"/>
+            <a:ext cx="5388899" cy="3951288"/>
           </a:xfrm>
         </p:spPr>
         <p:txBody>
@@ -2067,8 +2067,8 @@
         </p:nvSpPr>
         <p:spPr>
           <a:xfrm>
-            <a:off x="457200" y="273050"/>
-            <a:ext cx="3008313" cy="1162050"/>
+            <a:off x="609585" y="273050"/>
+            <a:ext cx="4010984" cy="1162050"/>
           </a:xfrm>
         </p:spPr>
         <p:txBody>
@@ -2099,8 +2099,8 @@
         </p:nvSpPr>
         <p:spPr>
           <a:xfrm>
-            <a:off x="3575050" y="273050"/>
-            <a:ext cx="5111750" cy="5853113"/>
+            <a:off x="4766614" y="273050"/>
+            <a:ext cx="6815496" cy="5853113"/>
           </a:xfrm>
         </p:spPr>
         <p:txBody>
@@ -2184,8 +2184,8 @@
         </p:nvSpPr>
         <p:spPr>
           <a:xfrm>
-            <a:off x="457200" y="1435100"/>
-            <a:ext cx="3008313" cy="4691063"/>
+            <a:off x="609585" y="1435100"/>
+            <a:ext cx="4010984" cy="4691063"/>
           </a:xfrm>
         </p:spPr>
         <p:txBody>
@@ -2344,8 +2344,8 @@
         </p:nvSpPr>
         <p:spPr>
           <a:xfrm>
-            <a:off x="1792288" y="4800600"/>
-            <a:ext cx="5486400" cy="566738"/>
+            <a:off x="2389658" y="4800600"/>
+            <a:ext cx="7315017" cy="566738"/>
           </a:xfrm>
         </p:spPr>
         <p:txBody>
@@ -2376,8 +2376,8 @@
         </p:nvSpPr>
         <p:spPr>
           <a:xfrm>
-            <a:off x="1792288" y="612775"/>
-            <a:ext cx="5486400" cy="4114800"/>
+            <a:off x="2389658" y="612775"/>
+            <a:ext cx="7315017" cy="4114800"/>
           </a:xfrm>
         </p:spPr>
         <p:txBody>
@@ -2437,8 +2437,8 @@
         </p:nvSpPr>
         <p:spPr>
           <a:xfrm>
-            <a:off x="1792288" y="5367338"/>
-            <a:ext cx="5486400" cy="804862"/>
+            <a:off x="2389658" y="5367338"/>
+            <a:ext cx="7315017" cy="804862"/>
           </a:xfrm>
         </p:spPr>
         <p:txBody>
@@ -2602,8 +2602,8 @@
         </p:nvSpPr>
         <p:spPr>
           <a:xfrm>
-            <a:off x="457200" y="274638"/>
-            <a:ext cx="8229600" cy="1143000"/>
+            <a:off x="609585" y="274638"/>
+            <a:ext cx="10972526" cy="1143000"/>
           </a:xfrm>
           <a:prstGeom prst="rect">
             <a:avLst/>
@@ -2635,8 +2635,8 @@
         </p:nvSpPr>
         <p:spPr>
           <a:xfrm>
-            <a:off x="457200" y="1600200"/>
-            <a:ext cx="8229600" cy="4525963"/>
+            <a:off x="609585" y="1600200"/>
+            <a:ext cx="10972526" cy="4525963"/>
           </a:xfrm>
           <a:prstGeom prst="rect">
             <a:avLst/>
@@ -2697,8 +2697,8 @@
         </p:nvSpPr>
         <p:spPr>
           <a:xfrm>
-            <a:off x="457200" y="6356350"/>
-            <a:ext cx="2133600" cy="365125"/>
+            <a:off x="609585" y="6356350"/>
+            <a:ext cx="2844729" cy="365125"/>
           </a:xfrm>
           <a:prstGeom prst="rect">
             <a:avLst/>
@@ -2738,8 +2738,8 @@
         </p:nvSpPr>
         <p:spPr>
           <a:xfrm>
-            <a:off x="3124200" y="6356350"/>
-            <a:ext cx="2895600" cy="365125"/>
+            <a:off x="4165496" y="6356350"/>
+            <a:ext cx="3860703" cy="365125"/>
           </a:xfrm>
           <a:prstGeom prst="rect">
             <a:avLst/>
@@ -2775,8 +2775,8 @@
         </p:nvSpPr>
         <p:spPr>
           <a:xfrm>
-            <a:off x="6553200" y="6356350"/>
-            <a:ext cx="2133600" cy="365125"/>
+            <a:off x="8737382" y="6356350"/>
+            <a:ext cx="2844729" cy="365125"/>
           </a:xfrm>
           <a:prstGeom prst="rect">
             <a:avLst/>

</xml_diff>